<commit_message>
Presentation: revise speaker notes for slides 1 to 15 in Dante's own wording
Rewrites the spoken script on slides 1-15 to match how Dante presents
(simpler cost wording on slide 2, general description of the example
questions on slide 5, significance explained before it is used on slide
11, McNemar results on slide 13, trimmed cost slide 14). Prep answer 6
now explains that the answers-kept assumption leaves the routing labels
untouched and favours the policies that over-route.
</commit_message>
<xml_diff>
--- a/documents/Presentation/Dante_Wesslund_Thesis_Presentation_v2_clean.pptx
+++ b/documents/Presentation/Dante_Wesslund_Thesis_Presentation_v2_clean.pptx
@@ -1257,7 +1257,7 @@
           <a:lstStyle/>
           <a:p>
             <a:r>
-              <a:t>[14:05 to 15:25]</a:t>
+              <a:t>[14:05 to 15:10]</a:t>
             </a:r>
           </a:p>
           <a:p>
@@ -1272,12 +1272,12 @@
           </a:p>
           <a:p>
             <a:r>
-              <a:t>So the signal is largely question structure, plus some precision on top. That is also a warning: part of it is how this benchmark builds its questions. One weak spot: on bridge-comparison questions, ModernBERT found only 1 of the 8 that needed Mix in the test set.</a:t>
-            </a:r>
-          </a:p>
-          <a:p>
-            <a:r>
-              <a:t>Next: what that precision means for the actual routing decisions.</a:t>
+              <a:t>So the signal is largely question structure, plus some precision on top.</a:t>
+            </a:r>
+          </a:p>
+          <a:p>
+            <a:r>
+              <a:t>Now, what does that precision mean for the actual routing decisions?</a:t>
             </a:r>
           </a:p>
         </p:txBody>
@@ -1347,7 +1347,7 @@
           <a:lstStyle/>
           <a:p>
             <a:r>
-              <a:t>[15:25 to 16:40]</a:t>
+              <a:t>[15:10 to 16:45]</a:t>
             </a:r>
           </a:p>
           <a:p>
@@ -1357,17 +1357,22 @@
           </a:p>
           <a:p>
             <a:r>
-              <a:t>On the left, unnecessary Mix calls: Naive was enough, but the router chose Mix anyway. That only wastes compute. TF-IDF makes 30 of these, ModernBERT 10. ModernBERT avoids 20 of TF-IDF's mistakes and makes no new ones. A McNemar test, which looks only at the questions where the two routers disagree, here 20 against 0, gives p below 0.001.</a:t>
-            </a:r>
-          </a:p>
-          <a:p>
-            <a:r>
-              <a:t>On the right, missed Mix calls: the question needed Mix but went to Naive. Those are the dangerous ones, because the answer suffers. ModernBERT misses 16, TF-IDF 11. The gap comes from seven questions, six one way and one the other, and it is not significant.</a:t>
-            </a:r>
-          </a:p>
-          <a:p>
-            <a:r>
-              <a:t>[pause] So: much less wasted compute, for a small and statistically unresolved increase in risk. Which side you prefer depends on what a wasted Mix call costs compared with a worse answer. Next: what that means for cost.</a:t>
+              <a:t>On the left, we see unnecessary Mix calls, where Naive was enough but the router chose Mix anyway, which is a waste of compute. TF-IDF makes 30 of these, while ModernBERT only makes 10. ModernBERT also avoids 20 of TF-IDF's mistakes while not making any new ones. A McNemar test, which looks only at the questions where the two routers disagree, here 20 against 0, gives p below 0.001.</a:t>
+            </a:r>
+          </a:p>
+          <a:p>
+            <a:r>
+              <a:t>On the right, we see missed Mix calls, which is where the question needed Mix but went to Naive instead. Those are the dangerous ones, because the answer suffers. ModernBERT misses 16 here, while TF-IDF only misses 11. The gap comes from just 7 questions where the routers disagree, and using McNemar we get a p-value of 0.125, so it is not significant.</a:t>
+            </a:r>
+          </a:p>
+          <a:p>
+            <a:r>
+              <a:t>[pause] So overall, ModernBERT wastes much less compute, at the price of a small increase in risk that we cannot statistically confirm. Which of the two you would prefer depends on what a wasted Mix call costs, compared with a worse answer.</a:t>
+            </a:r>
+          </a:p>
+          <a:p>
+            <a:r>
+              <a:t>Now, what does this mean for cost?</a:t>
             </a:r>
           </a:p>
         </p:txBody>
@@ -1437,32 +1442,22 @@
           <a:lstStyle/>
           <a:p>
             <a:r>
-              <a:t>[16:40 to 17:55]</a:t>
-            </a:r>
-          </a:p>
-          <a:p>
-            <a:r>
-              <a:t>Now the second part of the research question: cost.</a:t>
-            </a:r>
-          </a:p>
-          <a:p>
-            <a:r>
-              <a:t>On the left, mean time per question, measured on every test question. Always using Mix takes 24.4 seconds, always using Naive 10.9. Routing with TF-IDF gives 17.0 seconds, and routing with ModernBERT 14.1: 42 percent less than always-Mix. ModernBERT's routing is also significantly faster than TF-IDF's, by about 2.9 seconds per question, because it makes far fewer unnecessary Mix calls.</a:t>
-            </a:r>
-          </a:p>
-          <a:p>
-            <a:r>
-              <a:t>On the right, language-model tokens per question. ModernBERT routing uses under 7,000 tokens per question, against almost 18,000 for always-Mix: 63 percent fewer.</a:t>
-            </a:r>
-          </a:p>
-          <a:p>
-            <a:r>
-              <a:t>Two caveats. The token numbers are estimates from per-mode averages over 15 instrumented questions, while the times are measured. And the router's own running time is not included. It is three small encoder passes and no language-model call, next to retrieval calls of about 11 to 24 seconds, but I did not measure it.</a:t>
-            </a:r>
-          </a:p>
-          <a:p>
-            <a:r>
-              <a:t>In other words: the time saving is measured, the token saving is estimated, and both point the same way.</a:t>
+              <a:t>[16:45 to 17:40]</a:t>
+            </a:r>
+          </a:p>
+          <a:p>
+            <a:r>
+              <a:t>On the left, we see the mean time per question, measured on every test question. Always using Mix takes 24.4 seconds, while always using Naive takes 10.9 seconds. Routing with TF-IDF takes 17 seconds, and routing with ModernBERT takes 14.1 seconds, which is 42 percent less than always using Mix. ModernBERT's routing is also significantly faster than TF-IDF's, by about 2.9 seconds per question, which is because it makes far fewer unnecessary Mix calls.</a:t>
+            </a:r>
+          </a:p>
+          <a:p>
+            <a:r>
+              <a:t>On the right, we see tokens per question. ModernBERT routing uses under 7,000 tokens per question, compared to almost 18,000 for always-Mix, which is 63 percent fewer tokens.</a:t>
+            </a:r>
+          </a:p>
+          <a:p>
+            <a:r>
+              <a:t>In other words: ModernBERT saves the most time and tokens out of the relevant routers.</a:t>
             </a:r>
           </a:p>
         </p:txBody>
@@ -1602,12 +1597,12 @@
           <a:lstStyle/>
           <a:p>
             <a:r>
-              <a:t>[17:55 to 19:05]</a:t>
-            </a:r>
-          </a:p>
-          <a:p>
-            <a:r>
-              <a:t>What does that saving cost in answer quality?</a:t>
+              <a:t>[17:40 to 18:50]</a:t>
+            </a:r>
+          </a:p>
+          <a:p>
+            <a:r>
+              <a:t>So, what do those savings cost in answer quality?</a:t>
             </a:r>
           </a:p>
           <a:p>
@@ -1697,7 +1692,7 @@
           <a:lstStyle/>
           <a:p>
             <a:r>
-              <a:t>[19:05 to 20:45]</a:t>
+              <a:t>[18:50 to 20:30]</a:t>
             </a:r>
           </a:p>
           <a:p>
@@ -1792,7 +1787,7 @@
           <a:lstStyle/>
           <a:p>
             <a:r>
-              <a:t>[20:45 to 22:15]</a:t>
+              <a:t>[20:30 to 21:55]</a:t>
             </a:r>
           </a:p>
           <a:p>
@@ -1887,7 +1882,7 @@
           <a:lstStyle/>
           <a:p>
             <a:r>
-              <a:t>[22:15 to 23:45]</a:t>
+              <a:t>[21:55 to 23:25]</a:t>
             </a:r>
           </a:p>
           <a:p>
@@ -1987,7 +1982,7 @@
           <a:lstStyle/>
           <a:p>
             <a:r>
-              <a:t>[23:45 to 25:10]</a:t>
+              <a:t>[23:25 to 24:55]</a:t>
             </a:r>
           </a:p>
           <a:p>
@@ -2087,7 +2082,7 @@
           <a:lstStyle/>
           <a:p>
             <a:r>
-              <a:t>[25:10 to 25:20]</a:t>
+              <a:t>[24:55 to 25:00]</a:t>
             </a:r>
           </a:p>
           <a:p>

</xml_diff>

<commit_message>
Presentation: opposition answers, slide 16 to three points, prep updates
- Opposition_answers.md: Pontus's ten questions in his order, each with a
  two-minute spoken answer
- Slide 16 (In practice) drops the sustainability card and now has three
  points in one row; speaker notes match
- Defense_prep.md: answers to each point of the written opposition review
  (3b) and the ten opposition questions with short answers (3c)
</commit_message>
<xml_diff>
--- a/documents/Presentation/Dante_Wesslund_Thesis_Presentation_v2_clean.pptx
+++ b/documents/Presentation/Dante_Wesslund_Thesis_Presentation_v2_clean.pptx
@@ -1692,12 +1692,12 @@
           <a:lstStyle/>
           <a:p>
             <a:r>
-              <a:t>[18:50 to 20:30]</a:t>
-            </a:r>
-          </a:p>
-          <a:p>
-            <a:r>
-              <a:t>So what does this mean in practice? Four points.</a:t>
+              <a:t>[18:50 to 20:05]</a:t>
+            </a:r>
+          </a:p>
+          <a:p>
+            <a:r>
+              <a:t>So what does this mean in practice? Three points.</a:t>
             </a:r>
           </a:p>
           <a:p>
@@ -1713,11 +1713,6 @@
           <a:p>
             <a:r>
               <a:t>Third, the threshold is a cost dial. Where a weak answer is expensive, you lower it and send more to Mix. Where compute is the constraint, you raise it.</a:t>
-            </a:r>
-          </a:p>
-          <a:p>
-            <a:r>
-              <a:t>Fourth, sustainability and ethics. Fewer Mix calls should mean less energy, which ties to the UN goal on responsible consumption, though I did not measure energy. And a router can serve some question types worse, like bridge-comparison here, so quality should be monitored per question type, not only on average.</a:t>
             </a:r>
           </a:p>
         </p:txBody>
@@ -1787,7 +1782,7 @@
           <a:lstStyle/>
           <a:p>
             <a:r>
-              <a:t>[20:30 to 21:55]</a:t>
+              <a:t>[20:05 to 21:30]</a:t>
             </a:r>
           </a:p>
           <a:p>
@@ -1882,7 +1877,7 @@
           <a:lstStyle/>
           <a:p>
             <a:r>
-              <a:t>[21:55 to 23:25]</a:t>
+              <a:t>[21:30 to 23:05]</a:t>
             </a:r>
           </a:p>
           <a:p>
@@ -1982,7 +1977,7 @@
           <a:lstStyle/>
           <a:p>
             <a:r>
-              <a:t>[23:25 to 24:55]</a:t>
+              <a:t>[23:05 to 24:30]</a:t>
             </a:r>
           </a:p>
           <a:p>
@@ -2082,7 +2077,7 @@
           <a:lstStyle/>
           <a:p>
             <a:r>
-              <a:t>[24:55 to 25:00]</a:t>
+              <a:t>[24:30 to 24:40]</a:t>
             </a:r>
           </a:p>
           <a:p>
@@ -33735,8 +33730,8 @@
         </p:nvSpPr>
         <p:spPr>
           <a:xfrm>
-            <a:off x="603504" y="1965960"/>
-            <a:ext cx="5358384" cy="1874519"/>
+            <a:off x="603504" y="2103120"/>
+            <a:ext cx="3480816" cy="3108960"/>
           </a:xfrm>
           <a:prstGeom prst="roundRect">
             <a:avLst>
@@ -33797,7 +33792,7 @@
               </a:spcAft>
             </a:pPr>
             <a:r>
-              <a:rPr sz="1900" b="0" i="0">
+              <a:rPr sz="2000" b="0" i="0">
                 <a:solidFill>
                   <a:srgbClr val="333333"/>
                 </a:solidFill>
@@ -33816,8 +33811,8 @@
         </p:nvSpPr>
         <p:spPr>
           <a:xfrm>
-            <a:off x="6236208" y="1965960"/>
-            <a:ext cx="5358384" cy="1874519"/>
+            <a:off x="4358640" y="2103120"/>
+            <a:ext cx="3480816" cy="3108960"/>
           </a:xfrm>
           <a:prstGeom prst="roundRect">
             <a:avLst>
@@ -33878,7 +33873,7 @@
               </a:spcAft>
             </a:pPr>
             <a:r>
-              <a:rPr sz="1900" b="0" i="0">
+              <a:rPr sz="2000" b="0" i="0">
                 <a:solidFill>
                   <a:srgbClr val="333333"/>
                 </a:solidFill>
@@ -33897,8 +33892,8 @@
         </p:nvSpPr>
         <p:spPr>
           <a:xfrm>
-            <a:off x="603504" y="4114800"/>
-            <a:ext cx="5358384" cy="1874519"/>
+            <a:off x="8113776" y="2103120"/>
+            <a:ext cx="3480816" cy="3108960"/>
           </a:xfrm>
           <a:prstGeom prst="roundRect">
             <a:avLst>
@@ -33959,94 +33954,13 @@
               </a:spcAft>
             </a:pPr>
             <a:r>
-              <a:rPr sz="1900" b="0" i="0">
+              <a:rPr sz="2000" b="0" i="0">
                 <a:solidFill>
                   <a:srgbClr val="333333"/>
                 </a:solidFill>
                 <a:latin typeface="Figtree"/>
               </a:rPr>
               <a:t>The threshold trades wasted Mix calls against missed ones. Each deployment sets its own.</a:t>
-            </a:r>
-          </a:p>
-        </p:txBody>
-      </p:sp>
-      <p:sp>
-        <p:nvSpPr>
-          <p:cNvPr id="9" name="Rounded Rectangle 8"/>
-          <p:cNvSpPr/>
-          <p:nvPr/>
-        </p:nvSpPr>
-        <p:spPr>
-          <a:xfrm>
-            <a:off x="6236208" y="4114800"/>
-            <a:ext cx="5358384" cy="1874519"/>
-          </a:xfrm>
-          <a:prstGeom prst="roundRect">
-            <a:avLst>
-              <a:gd name="adj" fmla="val 5000"/>
-            </a:avLst>
-          </a:prstGeom>
-          <a:solidFill>
-            <a:srgbClr val="DEF0FF"/>
-          </a:solidFill>
-          <a:ln>
-            <a:noFill/>
-          </a:ln>
-          <a:effectLst/>
-        </p:spPr>
-        <p:style>
-          <a:lnRef idx="1">
-            <a:schemeClr val="accent1"/>
-          </a:lnRef>
-          <a:fillRef idx="3">
-            <a:schemeClr val="accent1"/>
-          </a:fillRef>
-          <a:effectRef idx="2">
-            <a:schemeClr val="accent1"/>
-          </a:effectRef>
-          <a:fontRef idx="minor">
-            <a:schemeClr val="lt1"/>
-          </a:fontRef>
-        </p:style>
-        <p:txBody>
-          <a:bodyPr rtlCol="0" anchor="t" lIns="256032" rIns="256032" tIns="256032" bIns="256032" wrap="square"/>
-          <a:lstStyle/>
-          <a:p>
-            <a:pPr algn="l">
-              <a:lnSpc>
-                <a:spcPct val="105000"/>
-              </a:lnSpc>
-              <a:spcAft>
-                <a:spcPts val="800"/>
-              </a:spcAft>
-            </a:pPr>
-            <a:r>
-              <a:rPr sz="2400" b="1" i="0">
-                <a:solidFill>
-                  <a:srgbClr val="004791"/>
-                </a:solidFill>
-                <a:latin typeface="Figtree"/>
-              </a:rPr>
-              <a:t>Sustainability and ethics</a:t>
-            </a:r>
-          </a:p>
-          <a:p>
-            <a:pPr algn="l">
-              <a:lnSpc>
-                <a:spcPct val="110000"/>
-              </a:lnSpc>
-              <a:spcAft>
-                <a:spcPts val="600"/>
-              </a:spcAft>
-            </a:pPr>
-            <a:r>
-              <a:rPr sz="1900" b="0" i="0">
-                <a:solidFill>
-                  <a:srgbClr val="333333"/>
-                </a:solidFill>
-                <a:latin typeface="Figtree"/>
-              </a:rPr>
-              <a:t>Fewer Mix calls should save energy (not measured). Monitor quality per question type, not just on average.</a:t>
             </a:r>
           </a:p>
         </p:txBody>
@@ -45020,7 +44934,7 @@
         <p:spPr>
           <a:xfrm>
             <a:off x="603504" y="1965960"/>
-            <a:ext cx="5358384" cy="1874519"/>
+            <a:ext cx="5358383" cy="1874519"/>
           </a:xfrm>
           <a:prstGeom prst="roundRect">
             <a:avLst>
@@ -45100,8 +45014,8 @@
         </p:nvSpPr>
         <p:spPr>
           <a:xfrm>
-            <a:off x="6236208" y="1965960"/>
-            <a:ext cx="5358384" cy="1874519"/>
+            <a:off x="6236207" y="1965960"/>
+            <a:ext cx="5358383" cy="1874519"/>
           </a:xfrm>
           <a:prstGeom prst="roundRect">
             <a:avLst>
@@ -45182,7 +45096,7 @@
         <p:spPr>
           <a:xfrm>
             <a:off x="603504" y="4114800"/>
-            <a:ext cx="5358384" cy="1874519"/>
+            <a:ext cx="5358383" cy="1874519"/>
           </a:xfrm>
           <a:prstGeom prst="roundRect">
             <a:avLst>
@@ -45262,8 +45176,8 @@
         </p:nvSpPr>
         <p:spPr>
           <a:xfrm>
-            <a:off x="6236208" y="4114800"/>
-            <a:ext cx="5358384" cy="1874519"/>
+            <a:off x="6236207" y="4114800"/>
+            <a:ext cx="5358383" cy="1874519"/>
           </a:xfrm>
           <a:prstGeom prst="roundRect">
             <a:avLst>

</xml_diff>

<commit_message>
Presentation: final notes, slide 18 and 19 speaker notes
- Slide 18 notes drop the generative-AI disclosure; Defense_prep marks it
  as an answer to give only if asked (thesis Section 5.7)
- Slide 19 notes: "My contributions are the following", ending at
  "lies in precision, and so in cost"
- Rebuilt the pptx, Speaker_script_v2_clean.md and presentation.html from
  build_clean.py; only the notes of slides 18-20 change (20 for its time
  stamp), the talk is now about 24.1 minutes
- Final_notes.md: significance and the tests explained, lines to say
  differently in the talk, prep wordings not to repeat (checked against
  the thesis and results/), and likely examiner questions the prep does
  not cover; listed in the README
</commit_message>
<xml_diff>
--- a/documents/Presentation/Dante_Wesslund_Thesis_Presentation_v2_clean.pptx
+++ b/documents/Presentation/Dante_Wesslund_Thesis_Presentation_v2_clean.pptx
@@ -1877,7 +1877,7 @@
           <a:lstStyle/>
           <a:p>
             <a:r>
-              <a:t>[21:30 to 23:05]</a:t>
+              <a:t>[21:30 to 22:35]</a:t>
             </a:r>
           </a:p>
           <a:p>
@@ -1903,11 +1903,6 @@
           <a:p>
             <a:r>
               <a:t>The first two come first, because they strengthen the numbers I already have.</a:t>
-            </a:r>
-          </a:p>
-          <a:p>
-            <a:r>
-              <a:t>Before I conclude, one disclosure, as in Section 5.7 of the thesis: I used Codex and Claude Code as assistants, for wording and for drafting and debugging code, including analysis code and the scripts that build these slides. I reviewed and ran everything myself, every number comes from my own runs, and the research question, design and conclusions are mine. Let me close with the conclusions.</a:t>
             </a:r>
           </a:p>
         </p:txBody>
@@ -1977,7 +1972,7 @@
           <a:lstStyle/>
           <a:p>
             <a:r>
-              <a:t>[23:05 to 24:30]</a:t>
+              <a:t>[22:35 to 24:00]</a:t>
             </a:r>
           </a:p>
           <a:p>
@@ -2002,7 +1997,7 @@
           </a:p>
           <a:p>
             <a:r>
-              <a:t>My contributions are three: a statistically tested study of query-only routing between a vector mode and a graph mode, an open and reproducible pipeline and judge-labelled dataset, and the finding that the encoder's advantage lies in precision, and so in cost, rather than in a demonstrably better ranking.</a:t>
+              <a:t>My contributions are the following: a statistically tested study of query-only routing between a vector mode and a graph mode, an open and reproducible pipeline and judge-labelled dataset, and the finding that the encoder's advantage lies in precision, and so in cost.</a:t>
             </a:r>
           </a:p>
           <a:p>
@@ -2077,7 +2072,7 @@
           <a:lstStyle/>
           <a:p>
             <a:r>
-              <a:t>[24:30 to 24:40]</a:t>
+              <a:t>[24:00 to 24:05]</a:t>
             </a:r>
           </a:p>
           <a:p>

</xml_diff>